<commit_message>
Drop the rejected figure variants; update the presented deck
The four deleted PNGs are the alternates from two design comparisons.
methods/draw_ladder_options.R emits three evaluation-ladder layouts and
methods/draw_pipeline_options.R emits three pipeline layouts; the kept
versions (evaluation_ladder.png, evaluation_ladder_rows.png,
pipeline_option_B.png) stay, and the variants that lost go. No document
references any of the four, so nothing breaks. Both generator scripts
still write them, so rerunning either recreates the files.

slides/lessons_getting_more_signal_from_snap_qc_data.pptx is the
presented deck, 3.56 MB to 4.02 MB.

Co-Authored-By: Claude Opus 5 (1M context) <noreply@anthropic.com>
</commit_message>
<xml_diff>
--- a/slides/lessons_getting_more_signal_from_snap_qc_data.pptx
+++ b/slides/lessons_getting_more_signal_from_snap_qc_data.pptx
@@ -289,7 +289,7 @@
       <p15:sldGuideLst xmlns:p15="http://schemas.microsoft.com/office/powerpoint/2012/main"/>
     </p:ext>
     <p:ext uri="GoogleSlidesCustomDataVersion2">
-      <go:slidesCustomData xmlns:go="http://customooxmlschemas.google.com/" xmlns:ahyp="http://schemas.microsoft.com/office/drawing/2018/hyperlinkcolor" xmlns:p15="http://schemas.microsoft.com/office/powerpoint/2012/main" xmlns:p14="http://schemas.microsoft.com/office/powerpoint/2010/main" xmlns:com="http://schemas.openxmlformats.org/drawingml/2006/compatibility" xmlns:pvml="urn:schemas-microsoft-com:office:powerpoint" xmlns:v="urn:schemas-microsoft-com:vml" xmlns:o="urn:schemas-microsoft-com:office:office" xmlns:dgm="http://schemas.openxmlformats.org/drawingml/2006/diagram" xmlns:c="http://schemas.openxmlformats.org/drawingml/2006/chart" xmlns:mv="urn:schemas-microsoft-com:mac:vml" xmlns:mc="http://schemas.openxmlformats.org/markup-compatibility/2006" xmlns="" r:id="rId50" roundtripDataSignature="AMtx7miHiQSzGui/N0IV2pULBjiL6ibjVA=="/>
+      <go:slidesCustomData xmlns="" xmlns:mc="http://schemas.openxmlformats.org/markup-compatibility/2006" xmlns:mv="urn:schemas-microsoft-com:mac:vml" xmlns:c="http://schemas.openxmlformats.org/drawingml/2006/chart" xmlns:dgm="http://schemas.openxmlformats.org/drawingml/2006/diagram" xmlns:o="urn:schemas-microsoft-com:office:office" xmlns:v="urn:schemas-microsoft-com:vml" xmlns:pvml="urn:schemas-microsoft-com:office:powerpoint" xmlns:com="http://schemas.openxmlformats.org/drawingml/2006/compatibility" xmlns:p14="http://schemas.microsoft.com/office/powerpoint/2010/main" xmlns:p15="http://schemas.microsoft.com/office/powerpoint/2012/main" xmlns:ahyp="http://schemas.microsoft.com/office/drawing/2018/hyperlinkcolor" xmlns:go="http://customooxmlschemas.google.com/" r:id="rId50" roundtripDataSignature="AMtx7miHiQSzGui/N0IV2pULBjiL6ibjVA=="/>
     </p:ext>
   </p:extLst>
 </p:presentation>
@@ -8655,7 +8655,7 @@
         <p:spPr>
           <a:xfrm>
             <a:off x="236136" y="800000"/>
-            <a:ext cx="2645383" cy="2549416"/>
+            <a:ext cx="2645383" cy="2549375"/>
           </a:xfrm>
           <a:prstGeom prst="rect">
             <a:avLst/>
@@ -8684,6 +8684,66 @@
               <a:buNone/>
             </a:pPr>
             <a:r>
+              <a:rPr lang="en-US" sz="1100" b="0" i="0" u="none" strike="noStrike" cap="none" dirty="0">
+                <a:solidFill>
+                  <a:srgbClr val="000000"/>
+                </a:solidFill>
+                <a:latin typeface="Arial"/>
+                <a:ea typeface="Arial"/>
+                <a:cs typeface="Arial"/>
+                <a:sym typeface="Arial"/>
+              </a:rPr>
+              <a:t>On CART/</a:t>
+            </a:r>
+            <a:r>
+              <a:rPr lang="en-US" sz="1100" b="0" i="0" u="none" strike="noStrike" cap="none" dirty="0" err="1">
+                <a:solidFill>
+                  <a:srgbClr val="000000"/>
+                </a:solidFill>
+                <a:latin typeface="Arial"/>
+                <a:ea typeface="Arial"/>
+                <a:cs typeface="Arial"/>
+                <a:sym typeface="Arial"/>
+              </a:rPr>
+              <a:t>RuleFit</a:t>
+            </a:r>
+            <a:r>
+              <a:rPr lang="en-US" sz="1100" b="0" i="0" u="none" strike="noStrike" cap="none" dirty="0">
+                <a:solidFill>
+                  <a:srgbClr val="000000"/>
+                </a:solidFill>
+                <a:latin typeface="Arial"/>
+                <a:ea typeface="Arial"/>
+                <a:cs typeface="Arial"/>
+                <a:sym typeface="Arial"/>
+              </a:rPr>
+              <a:t>, strata bought +47% precision. On v2 (RF + </a:t>
+            </a:r>
+            <a:r>
+              <a:rPr lang="en-US" sz="1100" b="0" i="0" u="none" strike="noStrike" cap="none" dirty="0" err="1">
+                <a:solidFill>
+                  <a:srgbClr val="000000"/>
+                </a:solidFill>
+                <a:latin typeface="Arial"/>
+                <a:ea typeface="Arial"/>
+                <a:cs typeface="Arial"/>
+                <a:sym typeface="Arial"/>
+              </a:rPr>
+              <a:t>xgboost</a:t>
+            </a:r>
+            <a:r>
+              <a:rPr lang="en-US" sz="1100" b="0" i="0" u="none" strike="noStrike" cap="none" dirty="0">
+                <a:solidFill>
+                  <a:srgbClr val="000000"/>
+                </a:solidFill>
+                <a:latin typeface="Arial"/>
+                <a:ea typeface="Arial"/>
+                <a:cs typeface="Arial"/>
+                <a:sym typeface="Arial"/>
+              </a:rPr>
+              <a:t>) the </a:t>
+            </a:r>
+            <a:r>
               <a:rPr lang="en-US" sz="1100" b="0" i="0" u="none" strike="noStrike" cap="none">
                 <a:solidFill>
                   <a:srgbClr val="000000"/>
@@ -8693,9 +8753,17 @@
                 <a:cs typeface="Arial"/>
                 <a:sym typeface="Arial"/>
               </a:rPr>
-              <a:t>On CART/RuleFit, strata bought +47% precision. On v2 (RF + xgboost) the margins flip by year, but the coarse split never loses.</a:t>
-            </a:r>
-            <a:endParaRPr/>
+              <a:t>coarse strata </a:t>
+            </a:r>
+            <a:r>
+              <a:rPr lang="en-US" sz="1100"/>
+              <a:t>remain </a:t>
+            </a:r>
+            <a:r>
+              <a:rPr lang="en-US" sz="1100" dirty="0"/>
+              <a:t>best, but gain is more modest. </a:t>
+            </a:r>
+            <a:endParaRPr dirty="0"/>
           </a:p>
           <a:p>
             <a:pPr marL="0" marR="0" lvl="0" indent="0" algn="l" rtl="0">
@@ -8711,7 +8779,7 @@
               <a:buNone/>
             </a:pPr>
             <a:r>
-              <a:rPr lang="en-US" sz="1100" b="0" i="0" u="none" strike="noStrike" cap="none">
+              <a:rPr lang="en-US" sz="1100" b="0" i="0" u="none" strike="noStrike" cap="none" dirty="0">
                 <a:solidFill>
                   <a:srgbClr val="000000"/>
                 </a:solidFill>
@@ -8722,7 +8790,7 @@
               </a:rPr>
               <a:t>- 2023: pooling matched precision; split won reach.</a:t>
             </a:r>
-            <a:endParaRPr/>
+            <a:endParaRPr dirty="0"/>
           </a:p>
           <a:p>
             <a:pPr marL="0" marR="0" lvl="0" indent="0" algn="l" rtl="0">
@@ -8738,7 +8806,7 @@
               <a:buNone/>
             </a:pPr>
             <a:r>
-              <a:rPr lang="en-US" sz="1100" b="0" i="0" u="none" strike="noStrike" cap="none">
+              <a:rPr lang="en-US" sz="1100" b="0" i="0" u="none" strike="noStrike" cap="none" dirty="0">
                 <a:solidFill>
                   <a:srgbClr val="000000"/>
                 </a:solidFill>
@@ -8749,7 +8817,7 @@
               </a:rPr>
               <a:t>- 2024 (chart): split wins precision (0.30 vs 0.26); pooling wins floor-reach (0.84 vs 0.79).</a:t>
             </a:r>
-            <a:endParaRPr/>
+            <a:endParaRPr dirty="0"/>
           </a:p>
           <a:p>
             <a:pPr marL="0" marR="0" lvl="0" indent="0" algn="l" rtl="0">
@@ -8765,7 +8833,7 @@
               <a:buNone/>
             </a:pPr>
             <a:r>
-              <a:rPr lang="en-US" sz="1100" b="0" i="0" u="none" strike="noStrike" cap="none">
+              <a:rPr lang="en-US" sz="1100" b="0" i="0" u="none" strike="noStrike" cap="none" dirty="0">
                 <a:solidFill>
                   <a:srgbClr val="000000"/>
                 </a:solidFill>
@@ -8776,7 +8844,7 @@
               </a:rPr>
               <a:t>- Best performance: strata 1 / 2-3 / 4+.</a:t>
             </a:r>
-            <a:endParaRPr/>
+            <a:endParaRPr dirty="0"/>
           </a:p>
           <a:p>
             <a:pPr marL="0" marR="0" lvl="0" indent="0" algn="l" rtl="0">
@@ -8792,7 +8860,7 @@
               <a:buNone/>
             </a:pPr>
             <a:r>
-              <a:rPr lang="en-US" sz="1100" b="0" i="0" u="none" strike="noStrike" cap="none">
+              <a:rPr lang="en-US" sz="1100" b="0" i="0" u="none" strike="noStrike" cap="none" dirty="0">
                 <a:solidFill>
                   <a:srgbClr val="000000"/>
                 </a:solidFill>
@@ -8803,7 +8871,7 @@
               </a:rPr>
               <a:t>- Elderly/disabled stratum stopped helping once mtry-2 forests arrived (parity checked).</a:t>
             </a:r>
-            <a:endParaRPr/>
+            <a:endParaRPr dirty="0"/>
           </a:p>
         </p:txBody>
       </p:sp>

</xml_diff>